<commit_message>
Add the English edition of the turkey biomarker deck
Ports all four slides, keeping Georgia/Calibri as the other English decks use.
The two versions carry an identical multiset of numeric values.

Fixes a table that was silently clipped in both languages: the results table's
column widths summed to 13.1 against a 12.1 table width, so the rightmost
column -- the cage screen verdict, which is the point of the slide -- was cut
off. Both decks now sum to exactly 12.1, and a check across every table in both
files confirms it.

Two English titles also wrapped to a second line and collided with the subtitle;
both are shortened.

Co-Authored-By: Claude Opus 5 <noreply@anthropic.com>
</commit_message>
<xml_diff>
--- a/slides/Turkey_Biomarkers_CH.pptx
+++ b/slides/Turkey_Biomarkers_CH.pptx
@@ -5277,13 +5277,13 @@
             <a:tbl>
               <a:tblPr/>
               <a:tblGrid>
-                <a:gridCol w="2743200"/>
-                <a:gridCol w="2377440"/>
-                <a:gridCol w="1280160"/>
-                <a:gridCol w="1828800"/>
+                <a:gridCol w="2651760"/>
+                <a:gridCol w="2194560"/>
+                <a:gridCol w="1188720"/>
+                <a:gridCol w="1737360"/>
                 <a:gridCol w="1005840"/>
+                <a:gridCol w="1097280"/>
                 <a:gridCol w="1188720"/>
-                <a:gridCol w="1463040"/>
               </a:tblGrid>
               <a:tr h="457200">
                 <a:tc>
@@ -7741,7 +7741,7 @@
                 <a:ea typeface="微软雅黑" pitchFamily="34" charset="-122"/>
                 <a:cs typeface="微软雅黑" pitchFamily="34" charset="-120"/>
               </a:rPr>
-              <a:t>19 个 FDR 显著的菌，经 L1 只剩 4 个。鸭队列也是如此——L1 正是把 19 收敛到 9 的那一步。</a:t>
+              <a:t>19 个菌达到 FDR&lt;0.05，经 L1 只剩 4 个。鸭队列也是如此——L1 正是把 19 收敛到 9 的那一步。</a:t>
             </a:r>
             <a:endParaRPr lang="en-US" sz="1100" dirty="0"/>
           </a:p>

</xml_diff>